<commit_message>
Rework Problem slide per working-draft v2 + add speaker notes
Rebuilds slide 2 as a clean five-row layout (~1M/yr new starts,
dose-by-feel paradox, 3-6mo trial-and-error, 7.4yr-vs-1yr contrast)
with the "titration is a craft run on recall" hook banner and a
data-cost footnote. Embeds the 80-second script, per-number Q&A
ammunition, and the informed-discontinuation ethics frame as slide
speaker notes. Full-English page; geometry verified on-slide.

Co-Authored-By: Claude Fable 5 <noreply@anthropic.com>
Claude-Session: https://claude.ai/code/session_01DaeVyPGzzxaoGLbSaA8uGB
</commit_message>
<xml_diff>
--- a/research/Attune_Milestone2.pptx
+++ b/research/Attune_Milestone2.pptx
@@ -7,17 +7,17 @@
   <p:sldIdLst>
     <p:sldId id="256" r:id="rId7"/>
     <p:sldId id="257" r:id="rId8"/>
-    <p:sldId id="258" r:id="rId9"/>
-    <p:sldId id="259" r:id="rId10"/>
-    <p:sldId id="260" r:id="rId11"/>
-    <p:sldId id="261" r:id="rId12"/>
-    <p:sldId id="262" r:id="rId13"/>
-    <p:sldId id="263" r:id="rId14"/>
-    <p:sldId id="264" r:id="rId15"/>
-    <p:sldId id="265" r:id="rId16"/>
-    <p:sldId id="266" r:id="rId17"/>
-    <p:sldId id="267" r:id="rId18"/>
-    <p:sldId id="268" r:id="rId19"/>
+    <p:sldId id="258" r:id="rId10"/>
+    <p:sldId id="259" r:id="rId11"/>
+    <p:sldId id="260" r:id="rId12"/>
+    <p:sldId id="261" r:id="rId13"/>
+    <p:sldId id="262" r:id="rId14"/>
+    <p:sldId id="263" r:id="rId15"/>
+    <p:sldId id="264" r:id="rId16"/>
+    <p:sldId id="265" r:id="rId17"/>
+    <p:sldId id="266" r:id="rId18"/>
+    <p:sldId id="267" r:id="rId19"/>
+    <p:sldId id="268" r:id="rId20"/>
   </p:sldIdLst>
   <p:sldSz cx="12191695" cy="6858000" type="screen4x3"/>
   <p:notesSz cx="6858000" cy="9144000"/>
@@ -117,6 +117,477 @@
     </a:lvl9pPr>
   </p:defaultTextStyle>
 </p:presentation>
+</file>
+
+<file path=ppt/notesMasters/notesMaster1.xml><?xml version="1.0" encoding="utf-8"?>
+<p:notesMaster xmlns:a="http://schemas.openxmlformats.org/drawingml/2006/main" xmlns:p="http://schemas.openxmlformats.org/presentationml/2006/main" xmlns:r="http://schemas.openxmlformats.org/officeDocument/2006/relationships">
+  <p:cSld>
+    <p:bg>
+      <p:bgRef idx="1001">
+        <a:schemeClr val="bg1"/>
+      </p:bgRef>
+    </p:bg>
+    <p:spTree>
+      <p:nvGrpSpPr>
+        <p:cNvPr id="1" name=""/>
+        <p:cNvGrpSpPr/>
+        <p:nvPr/>
+      </p:nvGrpSpPr>
+      <p:grpSpPr>
+        <a:xfrm>
+          <a:off x="0" y="0"/>
+          <a:ext cx="0" cy="0"/>
+          <a:chOff x="0" y="0"/>
+          <a:chExt cx="0" cy="0"/>
+        </a:xfrm>
+      </p:grpSpPr>
+      <p:sp>
+        <p:nvSpPr>
+          <p:cNvPr id="2" name="Header Placeholder 1"/>
+          <p:cNvSpPr>
+            <a:spLocks noGrp="1"/>
+          </p:cNvSpPr>
+          <p:nvPr>
+            <p:ph type="hdr" sz="quarter"/>
+          </p:nvPr>
+        </p:nvSpPr>
+        <p:spPr>
+          <a:xfrm>
+            <a:off x="0" y="0"/>
+            <a:ext cx="2971800" cy="457200"/>
+          </a:xfrm>
+          <a:prstGeom prst="rect">
+            <a:avLst/>
+          </a:prstGeom>
+        </p:spPr>
+        <p:txBody>
+          <a:bodyPr vert="horz" lIns="91440" tIns="45720" rIns="91440" bIns="45720" rtlCol="0"/>
+          <a:lstStyle>
+            <a:lvl1pPr algn="l">
+              <a:defRPr sz="1200"/>
+            </a:lvl1pPr>
+          </a:lstStyle>
+          <a:p>
+            <a:endParaRPr lang="en-US"/>
+          </a:p>
+        </p:txBody>
+      </p:sp>
+      <p:sp>
+        <p:nvSpPr>
+          <p:cNvPr id="3" name="Date Placeholder 2"/>
+          <p:cNvSpPr>
+            <a:spLocks noGrp="1"/>
+          </p:cNvSpPr>
+          <p:nvPr>
+            <p:ph type="dt" idx="1"/>
+          </p:nvPr>
+        </p:nvSpPr>
+        <p:spPr>
+          <a:xfrm>
+            <a:off x="3884613" y="0"/>
+            <a:ext cx="2971800" cy="457200"/>
+          </a:xfrm>
+          <a:prstGeom prst="rect">
+            <a:avLst/>
+          </a:prstGeom>
+        </p:spPr>
+        <p:txBody>
+          <a:bodyPr vert="horz" lIns="91440" tIns="45720" rIns="91440" bIns="45720" rtlCol="0"/>
+          <a:lstStyle>
+            <a:lvl1pPr algn="r">
+              <a:defRPr sz="1200"/>
+            </a:lvl1pPr>
+          </a:lstStyle>
+          <a:p>
+            <a:fld id="{0F89C1C7-3DCD-1040-A9CF-14679D8B5DDD}" type="datetimeFigureOut">
+              <a:rPr lang="en-US" smtClean="0"/>
+              <a:t>10/17/16</a:t>
+            </a:fld>
+            <a:endParaRPr lang="en-US"/>
+          </a:p>
+        </p:txBody>
+      </p:sp>
+      <p:sp>
+        <p:nvSpPr>
+          <p:cNvPr id="4" name="Slide Image Placeholder 3"/>
+          <p:cNvSpPr>
+            <a:spLocks noGrp="1" noRot="1" noChangeAspect="1"/>
+          </p:cNvSpPr>
+          <p:nvPr>
+            <p:ph type="sldImg" idx="2"/>
+          </p:nvPr>
+        </p:nvSpPr>
+        <p:spPr>
+          <a:xfrm>
+            <a:off x="1143000" y="685800"/>
+            <a:ext cx="4572000" cy="3429000"/>
+          </a:xfrm>
+          <a:prstGeom prst="rect">
+            <a:avLst/>
+          </a:prstGeom>
+          <a:noFill/>
+          <a:ln w="12700">
+            <a:solidFill>
+              <a:prstClr val="black"/>
+            </a:solidFill>
+          </a:ln>
+        </p:spPr>
+        <p:txBody>
+          <a:bodyPr vert="horz" lIns="91440" tIns="45720" rIns="91440" bIns="45720" rtlCol="0" anchor="ctr"/>
+          <a:lstStyle/>
+          <a:p>
+            <a:endParaRPr lang="en-US"/>
+          </a:p>
+        </p:txBody>
+      </p:sp>
+      <p:sp>
+        <p:nvSpPr>
+          <p:cNvPr id="5" name="Notes Placeholder 4"/>
+          <p:cNvSpPr>
+            <a:spLocks noGrp="1"/>
+          </p:cNvSpPr>
+          <p:nvPr>
+            <p:ph type="body" sz="quarter" idx="3"/>
+          </p:nvPr>
+        </p:nvSpPr>
+        <p:spPr>
+          <a:xfrm>
+            <a:off x="685800" y="4343400"/>
+            <a:ext cx="5486400" cy="4114800"/>
+          </a:xfrm>
+          <a:prstGeom prst="rect">
+            <a:avLst/>
+          </a:prstGeom>
+        </p:spPr>
+        <p:txBody>
+          <a:bodyPr vert="horz" lIns="91440" tIns="45720" rIns="91440" bIns="45720" rtlCol="0"/>
+          <a:lstStyle/>
+          <a:p>
+            <a:pPr lvl="0"/>
+            <a:r>
+              <a:rPr lang="en-US" smtClean="0"/>
+              <a:t>Click to edit Master text styles</a:t>
+            </a:r>
+          </a:p>
+          <a:p>
+            <a:pPr lvl="1"/>
+            <a:r>
+              <a:rPr lang="en-US" smtClean="0"/>
+              <a:t>Second level</a:t>
+            </a:r>
+          </a:p>
+          <a:p>
+            <a:pPr lvl="2"/>
+            <a:r>
+              <a:rPr lang="en-US" smtClean="0"/>
+              <a:t>Third level</a:t>
+            </a:r>
+          </a:p>
+          <a:p>
+            <a:pPr lvl="3"/>
+            <a:r>
+              <a:rPr lang="en-US" smtClean="0"/>
+              <a:t>Fourth level</a:t>
+            </a:r>
+          </a:p>
+          <a:p>
+            <a:pPr lvl="4"/>
+            <a:r>
+              <a:rPr lang="en-US" smtClean="0"/>
+              <a:t>Fifth level</a:t>
+            </a:r>
+            <a:endParaRPr lang="en-US"/>
+          </a:p>
+        </p:txBody>
+      </p:sp>
+      <p:sp>
+        <p:nvSpPr>
+          <p:cNvPr id="6" name="Footer Placeholder 5"/>
+          <p:cNvSpPr>
+            <a:spLocks noGrp="1"/>
+          </p:cNvSpPr>
+          <p:nvPr>
+            <p:ph type="ftr" sz="quarter" idx="4"/>
+          </p:nvPr>
+        </p:nvSpPr>
+        <p:spPr>
+          <a:xfrm>
+            <a:off x="0" y="8685213"/>
+            <a:ext cx="2971800" cy="457200"/>
+          </a:xfrm>
+          <a:prstGeom prst="rect">
+            <a:avLst/>
+          </a:prstGeom>
+        </p:spPr>
+        <p:txBody>
+          <a:bodyPr vert="horz" lIns="91440" tIns="45720" rIns="91440" bIns="45720" rtlCol="0" anchor="b"/>
+          <a:lstStyle>
+            <a:lvl1pPr algn="l">
+              <a:defRPr sz="1200"/>
+            </a:lvl1pPr>
+          </a:lstStyle>
+          <a:p>
+            <a:endParaRPr lang="en-US"/>
+          </a:p>
+        </p:txBody>
+      </p:sp>
+      <p:sp>
+        <p:nvSpPr>
+          <p:cNvPr id="7" name="Slide Number Placeholder 6"/>
+          <p:cNvSpPr>
+            <a:spLocks noGrp="1"/>
+          </p:cNvSpPr>
+          <p:nvPr>
+            <p:ph type="sldNum" sz="quarter" idx="5"/>
+          </p:nvPr>
+        </p:nvSpPr>
+        <p:spPr>
+          <a:xfrm>
+            <a:off x="3884613" y="8685213"/>
+            <a:ext cx="2971800" cy="457200"/>
+          </a:xfrm>
+          <a:prstGeom prst="rect">
+            <a:avLst/>
+          </a:prstGeom>
+        </p:spPr>
+        <p:txBody>
+          <a:bodyPr vert="horz" lIns="91440" tIns="45720" rIns="91440" bIns="45720" rtlCol="0" anchor="b"/>
+          <a:lstStyle>
+            <a:lvl1pPr algn="r">
+              <a:defRPr sz="1200"/>
+            </a:lvl1pPr>
+          </a:lstStyle>
+          <a:p>
+            <a:fld id="{BB5E49A5-4136-284D-997B-48E1D791AD67}" type="slidenum">
+              <a:rPr lang="en-US" smtClean="0"/>
+              <a:t>‹#›</a:t>
+            </a:fld>
+            <a:endParaRPr lang="en-US"/>
+          </a:p>
+        </p:txBody>
+      </p:sp>
+    </p:spTree>
+    <p:extLst>
+      <p:ext uri="{BB962C8B-B14F-4D97-AF65-F5344CB8AC3E}">
+        <p14:creationId xmlns:p14="http://schemas.microsoft.com/office/powerpoint/2010/main" val="2623252185"/>
+      </p:ext>
+    </p:extLst>
+  </p:cSld>
+  <p:clrMap bg1="lt1" tx1="dk1" bg2="lt2" tx2="dk2" accent1="accent1" accent2="accent2" accent3="accent3" accent4="accent4" accent5="accent5" accent6="accent6" hlink="hlink" folHlink="folHlink"/>
+  <p:notesStyle>
+    <a:lvl1pPr marL="0" algn="l" defTabSz="457200" rtl="0" eaLnBrk="1" latinLnBrk="0" hangingPunct="1">
+      <a:defRPr sz="1200" kern="1200">
+        <a:solidFill>
+          <a:schemeClr val="tx1"/>
+        </a:solidFill>
+        <a:latin typeface="+mn-lt"/>
+        <a:ea typeface="+mn-ea"/>
+        <a:cs typeface="+mn-cs"/>
+      </a:defRPr>
+    </a:lvl1pPr>
+    <a:lvl2pPr marL="457200" algn="l" defTabSz="457200" rtl="0" eaLnBrk="1" latinLnBrk="0" hangingPunct="1">
+      <a:defRPr sz="1200" kern="1200">
+        <a:solidFill>
+          <a:schemeClr val="tx1"/>
+        </a:solidFill>
+        <a:latin typeface="+mn-lt"/>
+        <a:ea typeface="+mn-ea"/>
+        <a:cs typeface="+mn-cs"/>
+      </a:defRPr>
+    </a:lvl2pPr>
+    <a:lvl3pPr marL="914400" algn="l" defTabSz="457200" rtl="0" eaLnBrk="1" latinLnBrk="0" hangingPunct="1">
+      <a:defRPr sz="1200" kern="1200">
+        <a:solidFill>
+          <a:schemeClr val="tx1"/>
+        </a:solidFill>
+        <a:latin typeface="+mn-lt"/>
+        <a:ea typeface="+mn-ea"/>
+        <a:cs typeface="+mn-cs"/>
+      </a:defRPr>
+    </a:lvl3pPr>
+    <a:lvl4pPr marL="1371600" algn="l" defTabSz="457200" rtl="0" eaLnBrk="1" latinLnBrk="0" hangingPunct="1">
+      <a:defRPr sz="1200" kern="1200">
+        <a:solidFill>
+          <a:schemeClr val="tx1"/>
+        </a:solidFill>
+        <a:latin typeface="+mn-lt"/>
+        <a:ea typeface="+mn-ea"/>
+        <a:cs typeface="+mn-cs"/>
+      </a:defRPr>
+    </a:lvl4pPr>
+    <a:lvl5pPr marL="1828800" algn="l" defTabSz="457200" rtl="0" eaLnBrk="1" latinLnBrk="0" hangingPunct="1">
+      <a:defRPr sz="1200" kern="1200">
+        <a:solidFill>
+          <a:schemeClr val="tx1"/>
+        </a:solidFill>
+        <a:latin typeface="+mn-lt"/>
+        <a:ea typeface="+mn-ea"/>
+        <a:cs typeface="+mn-cs"/>
+      </a:defRPr>
+    </a:lvl5pPr>
+    <a:lvl6pPr marL="2286000" algn="l" defTabSz="457200" rtl="0" eaLnBrk="1" latinLnBrk="0" hangingPunct="1">
+      <a:defRPr sz="1200" kern="1200">
+        <a:solidFill>
+          <a:schemeClr val="tx1"/>
+        </a:solidFill>
+        <a:latin typeface="+mn-lt"/>
+        <a:ea typeface="+mn-ea"/>
+        <a:cs typeface="+mn-cs"/>
+      </a:defRPr>
+    </a:lvl6pPr>
+    <a:lvl7pPr marL="2743200" algn="l" defTabSz="457200" rtl="0" eaLnBrk="1" latinLnBrk="0" hangingPunct="1">
+      <a:defRPr sz="1200" kern="1200">
+        <a:solidFill>
+          <a:schemeClr val="tx1"/>
+        </a:solidFill>
+        <a:latin typeface="+mn-lt"/>
+        <a:ea typeface="+mn-ea"/>
+        <a:cs typeface="+mn-cs"/>
+      </a:defRPr>
+    </a:lvl7pPr>
+    <a:lvl8pPr marL="3200400" algn="l" defTabSz="457200" rtl="0" eaLnBrk="1" latinLnBrk="0" hangingPunct="1">
+      <a:defRPr sz="1200" kern="1200">
+        <a:solidFill>
+          <a:schemeClr val="tx1"/>
+        </a:solidFill>
+        <a:latin typeface="+mn-lt"/>
+        <a:ea typeface="+mn-ea"/>
+        <a:cs typeface="+mn-cs"/>
+      </a:defRPr>
+    </a:lvl8pPr>
+    <a:lvl9pPr marL="3657600" algn="l" defTabSz="457200" rtl="0" eaLnBrk="1" latinLnBrk="0" hangingPunct="1">
+      <a:defRPr sz="1200" kern="1200">
+        <a:solidFill>
+          <a:schemeClr val="tx1"/>
+        </a:solidFill>
+        <a:latin typeface="+mn-lt"/>
+        <a:ea typeface="+mn-ea"/>
+        <a:cs typeface="+mn-cs"/>
+      </a:defRPr>
+    </a:lvl9pPr>
+  </p:notesStyle>
+</p:notesMaster>
+</file>
+
+<file path=ppt/notesSlides/notesSlide1.xml><?xml version="1.0" encoding="utf-8"?>
+<p:notes xmlns:a="http://schemas.openxmlformats.org/drawingml/2006/main" xmlns:p="http://schemas.openxmlformats.org/presentationml/2006/main" xmlns:r="http://schemas.openxmlformats.org/officeDocument/2006/relationships">
+  <p:cSld>
+    <p:spTree>
+      <p:nvGrpSpPr>
+        <p:cNvPr id="1" name=""/>
+        <p:cNvGrpSpPr/>
+        <p:nvPr/>
+      </p:nvGrpSpPr>
+      <p:grpSpPr>
+        <a:xfrm>
+          <a:off x="0" y="0"/>
+          <a:ext cx="0" cy="0"/>
+          <a:chOff x="0" y="0"/>
+          <a:chExt cx="0" cy="0"/>
+        </a:xfrm>
+      </p:grpSpPr>
+      <p:sp>
+        <p:nvSpPr>
+          <p:cNvPr id="2" name="Slide Image Placeholder 1"/>
+          <p:cNvSpPr>
+            <a:spLocks noGrp="1"/>
+          </p:cNvSpPr>
+          <p:nvPr>
+            <p:ph type="sldImg" idx="2"/>
+          </p:nvPr>
+        </p:nvSpPr>
+        <p:spPr/>
+      </p:sp>
+      <p:sp>
+        <p:nvSpPr>
+          <p:cNvPr id="3" name="Notes Placeholder 2"/>
+          <p:cNvSpPr>
+            <a:spLocks noGrp="1"/>
+          </p:cNvSpPr>
+          <p:nvPr>
+            <p:ph type="body" idx="3" sz="quarter"/>
+          </p:nvPr>
+        </p:nvSpPr>
+        <p:spPr/>
+        <p:txBody>
+          <a:bodyPr/>
+          <a:lstStyle/>
+          <a:p>
+            <a:r>
+              <a:t>SCRIPT (~80s):</a:t>
+            </a:r>
+          </a:p>
+          <a:p>
+            <a:r>
+              <a:t>Every year, about a million women in the US and Canada start hormone therapy for menopause — and perimenopause is the fastest-growing segment. The clinical guideline for this therapy is explicit: adjust the dose by her symptoms, not blood levels. But no one — no system — records those symptoms. So she enters three to six months of trial and error. Each dose change takes four to six weeks to judge. In those weeks she can't tell whether worsening anxiety means too little estrogen or too much, and late-night searches return horror stories. Her doctor decides the next step from what she can recall in a fifteen-minute visit. The result: her symptoms will last a median of 7.4 years, but half of women abandon the therapy within one. And to be precise — informed discontinuation is a good outcome; the problem is that 62% stop abruptly, against medical advice, in an information vacuum — and 84% of them relapse. Then they spend thirteen billion dollars a year on supplements that don't work. The problem isn't the medicine. Titration is a craft run on recall. It should be a data problem.</a:t>
+            </a:r>
+          </a:p>
+          <a:p/>
+          <a:p>
+            <a:r>
+              <a:t>Q&amp;A AMMO:</a:t>
+            </a:r>
+          </a:p>
+          <a:p>
+            <a:r>
+              <a:t>- ~1M/yr: MY ESTIMATE (say so proactively). Logic: ~2.5-3M current US users (JAMA: ~5% of postmenopausal women) x ~50% first-year discontinuation, with a growing stock — a 10-20k/month inflow could not sustain the pool. Validating with a claims-data slice. Supporting: Epic Research +86% Rx since 2021; Truveta: 1 in 20 women 45-54 hold an estrogen Rx.</a:t>
+            </a:r>
+          </a:p>
+          <a:p>
+            <a:r>
+              <a:t>- Dose by feel: NAMS 2022 Hormone Therapy Position Statement; ACOG concurs. Hormone levels fluctuate too much to guide dosing.</a:t>
+            </a:r>
+          </a:p>
+          <a:p>
+            <a:r>
+              <a:t>- 3-6 months / 4-6 weeks: clinical consensus; full effect up to 12 weeks.</a:t>
+            </a:r>
+          </a:p>
+          <a:p>
+            <a:r>
+              <a:t>- 7.4 years: SWAN study, JAMA Internal Medicine 2015, n=1,449 (Black women: median 10.1 yrs). If challenged 'symptom duration is not treatment duration': correct — the point is symptoms run in YEARS, abandonment happens in MONTHS, and 62% of it is against medical advice.</a:t>
+            </a:r>
+          </a:p>
+          <a:p>
+            <a:r>
+              <a:t>- Half quit yr 1: PubMed 10614674 — 48% (younger) to 62% (older); side-effects are the top stated reason (64-87%). Pharmacy DB: only 54-69% still on the ORIGINAL regimen at 1 yr.</a:t>
+            </a:r>
+          </a:p>
+          <a:p>
+            <a:r>
+              <a:t>- 62% abrupt / 84% relapse: BJOG 2025 systematic review (69 studies).</a:t>
+            </a:r>
+          </a:p>
+          <a:p>
+            <a:r>
+              <a:t>- $13B: AARP survey (&gt;$10B of it on non-medical products). +45%: actuarial analysis cited by Elektra Health.</a:t>
+            </a:r>
+          </a:p>
+          <a:p>
+            <a:r>
+              <a:t>ETHICS FRAME (say aloud, esp. to women's-health investors): our goal is not retention maximisation — informed quitting is a good outcome; panic quitting against advice is the system failure we target.</a:t>
+            </a:r>
+          </a:p>
+        </p:txBody>
+      </p:sp>
+      <p:sp>
+        <p:nvSpPr>
+          <p:cNvPr id="4" name="Slide Number Placeholder 3"/>
+          <p:cNvSpPr>
+            <a:spLocks noGrp="1"/>
+          </p:cNvSpPr>
+          <p:nvPr>
+            <p:ph type="sldNum" idx="5" sz="quarter"/>
+          </p:nvPr>
+        </p:nvSpPr>
+        <p:spPr/>
+      </p:sp>
+    </p:spTree>
+  </p:cSld>
+  <p:clrMapOvr>
+    <a:masterClrMapping/>
+  </p:clrMapOvr>
+</p:notes>
 </file>
 
 <file path=ppt/slideLayouts/slideLayout1.xml><?xml version="1.0" encoding="utf-8"?>
@@ -8543,7 +9014,7 @@
                 </a:solidFill>
                 <a:latin typeface="Arial"/>
               </a:rPr>
-              <a:t>A therapy you must dose "by feel" — with no way to record the feeling</a:t>
+              <a:t>A therapy dosed "by feel" — and no one records the feeling</a:t>
             </a:r>
           </a:p>
         </p:txBody>
@@ -8643,8 +9114,8 @@
       </p:sp>
       <p:sp>
         <p:nvSpPr>
-          <p:cNvPr id="8" name="TextBox 7"/>
-          <p:cNvSpPr txBox="1"/>
+          <p:cNvPr id="8" name="Rectangle 7"/>
+          <p:cNvSpPr/>
           <p:nvPr/>
         </p:nvSpPr>
         <p:spPr>
@@ -8655,73 +9126,11 @@
           <a:prstGeom prst="rect">
             <a:avLst/>
           </a:prstGeom>
-          <a:noFill/>
-        </p:spPr>
-        <p:txBody>
-          <a:bodyPr wrap="square" anchor="t" lIns="25400" rIns="25400" tIns="25400" bIns="25400">
-            <a:spAutoFit/>
-          </a:bodyPr>
-          <a:lstStyle/>
-          <a:p>
-            <a:pPr algn="l">
-              <a:lnSpc>
-                <a:spcPct val="115000"/>
-              </a:lnSpc>
-              <a:spcAft>
-                <a:spcPts val="400"/>
-              </a:spcAft>
-            </a:pPr>
-            <a:r>
-              <a:rPr sz="1600" b="0">
-                <a:solidFill>
-                  <a:srgbClr val="2B252A"/>
-                </a:solidFill>
-                <a:latin typeface="Arial"/>
-              </a:rPr>
-              <a:t>Menopause hormone therapy (HRT) must be </a:t>
-            </a:r>
-            <a:r>
-              <a:rPr sz="1600" b="1">
-                <a:solidFill>
-                  <a:srgbClr val="4A1F3D"/>
-                </a:solidFill>
-                <a:latin typeface="Arial"/>
-              </a:rPr>
-              <a:t>titrated by symptoms, not blood levels</a:t>
-            </a:r>
-            <a:r>
-              <a:rPr sz="1600" b="0">
-                <a:solidFill>
-                  <a:srgbClr val="2B252A"/>
-                </a:solidFill>
-                <a:latin typeface="Arial"/>
-              </a:rPr>
-              <a:t> — per NAMS/ACOG guidelines. Yet nothing records those symptoms.</a:t>
-            </a:r>
-          </a:p>
-        </p:txBody>
-      </p:sp>
-      <p:sp>
-        <p:nvSpPr>
-          <p:cNvPr id="9" name="Rounded Rectangle 8"/>
-          <p:cNvSpPr/>
-          <p:nvPr/>
-        </p:nvSpPr>
-        <p:spPr>
-          <a:xfrm>
-            <a:off x="548640" y="2423160"/>
-            <a:ext cx="3602736" cy="2286000"/>
-          </a:xfrm>
-          <a:prstGeom prst="roundRect">
-            <a:avLst/>
-          </a:prstGeom>
           <a:solidFill>
-            <a:srgbClr val="FBF8FA"/>
+            <a:srgbClr val="F6F1F4"/>
           </a:solidFill>
-          <a:ln w="12700">
-            <a:solidFill>
-              <a:srgbClr val="E3D8DF"/>
-            </a:solidFill>
+          <a:ln>
+            <a:noFill/>
           </a:ln>
           <a:effectLst/>
         </p:spPr>
@@ -8749,16 +9158,396 @@
       </p:sp>
       <p:sp>
         <p:nvSpPr>
-          <p:cNvPr id="10" name="Rectangle 9"/>
+          <p:cNvPr id="9" name="TextBox 8"/>
+          <p:cNvSpPr txBox="1"/>
+          <p:nvPr/>
+        </p:nvSpPr>
+        <p:spPr>
+          <a:xfrm>
+            <a:off x="777240" y="1325880"/>
+            <a:ext cx="3566160" cy="914400"/>
+          </a:xfrm>
+          <a:prstGeom prst="rect">
+            <a:avLst/>
+          </a:prstGeom>
+          <a:noFill/>
+        </p:spPr>
+        <p:txBody>
+          <a:bodyPr wrap="square" anchor="ctr" lIns="25400" rIns="25400" tIns="25400" bIns="25400">
+            <a:spAutoFit/>
+          </a:bodyPr>
+          <a:lstStyle/>
+          <a:p>
+            <a:pPr algn="l">
+              <a:lnSpc>
+                <a:spcPct val="100000"/>
+              </a:lnSpc>
+              <a:spcAft>
+                <a:spcPts val="400"/>
+              </a:spcAft>
+            </a:pPr>
+            <a:r>
+              <a:rPr sz="2000" b="1">
+                <a:solidFill>
+                  <a:srgbClr val="4A1F3D"/>
+                </a:solidFill>
+                <a:latin typeface="Arial"/>
+              </a:rPr>
+              <a:t>~1,000,000 / yr</a:t>
+            </a:r>
+          </a:p>
+        </p:txBody>
+      </p:sp>
+      <p:sp>
+        <p:nvSpPr>
+          <p:cNvPr id="10" name="TextBox 9"/>
+          <p:cNvSpPr txBox="1"/>
+          <p:nvPr/>
+        </p:nvSpPr>
+        <p:spPr>
+          <a:xfrm>
+            <a:off x="4480560" y="1325880"/>
+            <a:ext cx="6949440" cy="914400"/>
+          </a:xfrm>
+          <a:prstGeom prst="rect">
+            <a:avLst/>
+          </a:prstGeom>
+          <a:noFill/>
+        </p:spPr>
+        <p:txBody>
+          <a:bodyPr wrap="square" anchor="ctr" lIns="25400" rIns="25400" tIns="25400" bIns="25400">
+            <a:spAutoFit/>
+          </a:bodyPr>
+          <a:lstStyle/>
+          <a:p>
+            <a:pPr algn="l">
+              <a:lnSpc>
+                <a:spcPct val="105000"/>
+              </a:lnSpc>
+              <a:spcAft>
+                <a:spcPts val="400"/>
+              </a:spcAft>
+            </a:pPr>
+            <a:r>
+              <a:rPr sz="1350" b="0">
+                <a:solidFill>
+                  <a:srgbClr val="2B252A"/>
+                </a:solidFill>
+                <a:latin typeface="Arial"/>
+              </a:rPr>
+              <a:t>women start menopause hormone therapy in the US + Canada (est.) — perimenopause is the fastest-growing segment</a:t>
+            </a:r>
+          </a:p>
+        </p:txBody>
+      </p:sp>
+      <p:sp>
+        <p:nvSpPr>
+          <p:cNvPr id="11" name="TextBox 10"/>
+          <p:cNvSpPr txBox="1"/>
+          <p:nvPr/>
+        </p:nvSpPr>
+        <p:spPr>
+          <a:xfrm>
+            <a:off x="777240" y="2295144"/>
+            <a:ext cx="3566160" cy="914400"/>
+          </a:xfrm>
+          <a:prstGeom prst="rect">
+            <a:avLst/>
+          </a:prstGeom>
+          <a:noFill/>
+        </p:spPr>
+        <p:txBody>
+          <a:bodyPr wrap="square" anchor="ctr" lIns="25400" rIns="25400" tIns="25400" bIns="25400">
+            <a:spAutoFit/>
+          </a:bodyPr>
+          <a:lstStyle/>
+          <a:p>
+            <a:pPr algn="l">
+              <a:lnSpc>
+                <a:spcPct val="100000"/>
+              </a:lnSpc>
+              <a:spcAft>
+                <a:spcPts val="400"/>
+              </a:spcAft>
+            </a:pPr>
+            <a:r>
+              <a:rPr sz="2000" b="1">
+                <a:solidFill>
+                  <a:srgbClr val="4A1F3D"/>
+                </a:solidFill>
+                <a:latin typeface="Arial"/>
+              </a:rPr>
+              <a:t>"Dose by feel."</a:t>
+            </a:r>
+          </a:p>
+        </p:txBody>
+      </p:sp>
+      <p:sp>
+        <p:nvSpPr>
+          <p:cNvPr id="12" name="TextBox 11"/>
+          <p:cNvSpPr txBox="1"/>
+          <p:nvPr/>
+        </p:nvSpPr>
+        <p:spPr>
+          <a:xfrm>
+            <a:off x="4480560" y="2295144"/>
+            <a:ext cx="6949440" cy="914400"/>
+          </a:xfrm>
+          <a:prstGeom prst="rect">
+            <a:avLst/>
+          </a:prstGeom>
+          <a:noFill/>
+        </p:spPr>
+        <p:txBody>
+          <a:bodyPr wrap="square" anchor="ctr" lIns="25400" rIns="25400" tIns="25400" bIns="25400">
+            <a:spAutoFit/>
+          </a:bodyPr>
+          <a:lstStyle/>
+          <a:p>
+            <a:pPr algn="l">
+              <a:lnSpc>
+                <a:spcPct val="105000"/>
+              </a:lnSpc>
+              <a:spcAft>
+                <a:spcPts val="400"/>
+              </a:spcAft>
+            </a:pPr>
+            <a:r>
+              <a:rPr sz="1350" b="0">
+                <a:solidFill>
+                  <a:srgbClr val="2B252A"/>
+                </a:solidFill>
+                <a:latin typeface="Arial"/>
+              </a:rPr>
+              <a:t>NAMS/ACOG guidelines: titrate by her symptoms, not blood levels — yet no system records those symptoms</a:t>
+            </a:r>
+          </a:p>
+        </p:txBody>
+      </p:sp>
+      <p:sp>
+        <p:nvSpPr>
+          <p:cNvPr id="13" name="Rectangle 12"/>
           <p:cNvSpPr/>
           <p:nvPr/>
         </p:nvSpPr>
         <p:spPr>
           <a:xfrm>
-            <a:off x="548640" y="2423160"/>
-            <a:ext cx="3602736" cy="109728"/>
-          </a:xfrm>
-          <a:prstGeom prst="rect">
+            <a:off x="548640" y="3264408"/>
+            <a:ext cx="11064240" cy="914400"/>
+          </a:xfrm>
+          <a:prstGeom prst="rect">
+            <a:avLst/>
+          </a:prstGeom>
+          <a:solidFill>
+            <a:srgbClr val="F6F1F4"/>
+          </a:solidFill>
+          <a:ln>
+            <a:noFill/>
+          </a:ln>
+          <a:effectLst/>
+        </p:spPr>
+        <p:style>
+          <a:lnRef idx="1">
+            <a:schemeClr val="accent1"/>
+          </a:lnRef>
+          <a:fillRef idx="3">
+            <a:schemeClr val="accent1"/>
+          </a:fillRef>
+          <a:effectRef idx="2">
+            <a:schemeClr val="accent1"/>
+          </a:effectRef>
+          <a:fontRef idx="minor">
+            <a:schemeClr val="lt1"/>
+          </a:fontRef>
+        </p:style>
+        <p:txBody>
+          <a:bodyPr rtlCol="0" anchor="ctr"/>
+          <a:lstStyle/>
+          <a:p>
+            <a:pPr algn="ctr"/>
+          </a:p>
+        </p:txBody>
+      </p:sp>
+      <p:sp>
+        <p:nvSpPr>
+          <p:cNvPr id="14" name="TextBox 13"/>
+          <p:cNvSpPr txBox="1"/>
+          <p:nvPr/>
+        </p:nvSpPr>
+        <p:spPr>
+          <a:xfrm>
+            <a:off x="777240" y="3264408"/>
+            <a:ext cx="3566160" cy="914400"/>
+          </a:xfrm>
+          <a:prstGeom prst="rect">
+            <a:avLst/>
+          </a:prstGeom>
+          <a:noFill/>
+        </p:spPr>
+        <p:txBody>
+          <a:bodyPr wrap="square" anchor="ctr" lIns="25400" rIns="25400" tIns="25400" bIns="25400">
+            <a:spAutoFit/>
+          </a:bodyPr>
+          <a:lstStyle/>
+          <a:p>
+            <a:pPr algn="l">
+              <a:lnSpc>
+                <a:spcPct val="100000"/>
+              </a:lnSpc>
+              <a:spcAft>
+                <a:spcPts val="400"/>
+              </a:spcAft>
+            </a:pPr>
+            <a:r>
+              <a:rPr sz="2000" b="1">
+                <a:solidFill>
+                  <a:srgbClr val="4A1F3D"/>
+                </a:solidFill>
+                <a:latin typeface="Arial"/>
+              </a:rPr>
+              <a:t>3–6 months of trial &amp; error</a:t>
+            </a:r>
+          </a:p>
+        </p:txBody>
+      </p:sp>
+      <p:sp>
+        <p:nvSpPr>
+          <p:cNvPr id="15" name="TextBox 14"/>
+          <p:cNvSpPr txBox="1"/>
+          <p:nvPr/>
+        </p:nvSpPr>
+        <p:spPr>
+          <a:xfrm>
+            <a:off x="4480560" y="3264408"/>
+            <a:ext cx="6949440" cy="914400"/>
+          </a:xfrm>
+          <a:prstGeom prst="rect">
+            <a:avLst/>
+          </a:prstGeom>
+          <a:noFill/>
+        </p:spPr>
+        <p:txBody>
+          <a:bodyPr wrap="square" anchor="ctr" lIns="25400" rIns="25400" tIns="25400" bIns="25400">
+            <a:spAutoFit/>
+          </a:bodyPr>
+          <a:lstStyle/>
+          <a:p>
+            <a:pPr algn="l">
+              <a:lnSpc>
+                <a:spcPct val="105000"/>
+              </a:lnSpc>
+              <a:spcAft>
+                <a:spcPts val="400"/>
+              </a:spcAft>
+            </a:pPr>
+            <a:r>
+              <a:rPr sz="1350" b="0">
+                <a:solidFill>
+                  <a:srgbClr val="2B252A"/>
+                </a:solidFill>
+                <a:latin typeface="Arial"/>
+              </a:rPr>
+              <a:t>each dose change takes 4–6 weeks to judge; her doctor re-doses from a 15-minute recall</a:t>
+            </a:r>
+          </a:p>
+        </p:txBody>
+      </p:sp>
+      <p:sp>
+        <p:nvSpPr>
+          <p:cNvPr id="16" name="TextBox 15"/>
+          <p:cNvSpPr txBox="1"/>
+          <p:nvPr/>
+        </p:nvSpPr>
+        <p:spPr>
+          <a:xfrm>
+            <a:off x="777240" y="4233672"/>
+            <a:ext cx="3566160" cy="914400"/>
+          </a:xfrm>
+          <a:prstGeom prst="rect">
+            <a:avLst/>
+          </a:prstGeom>
+          <a:noFill/>
+        </p:spPr>
+        <p:txBody>
+          <a:bodyPr wrap="square" anchor="ctr" lIns="25400" rIns="25400" tIns="25400" bIns="25400">
+            <a:spAutoFit/>
+          </a:bodyPr>
+          <a:lstStyle/>
+          <a:p>
+            <a:pPr algn="l">
+              <a:lnSpc>
+                <a:spcPct val="100000"/>
+              </a:lnSpc>
+              <a:spcAft>
+                <a:spcPts val="400"/>
+              </a:spcAft>
+            </a:pPr>
+            <a:r>
+              <a:rPr sz="2000" b="1">
+                <a:solidFill>
+                  <a:srgbClr val="C96F8A"/>
+                </a:solidFill>
+                <a:latin typeface="Arial"/>
+              </a:rPr>
+              <a:t>7.4 yrs  vs  1 yr</a:t>
+            </a:r>
+          </a:p>
+        </p:txBody>
+      </p:sp>
+      <p:sp>
+        <p:nvSpPr>
+          <p:cNvPr id="17" name="TextBox 16"/>
+          <p:cNvSpPr txBox="1"/>
+          <p:nvPr/>
+        </p:nvSpPr>
+        <p:spPr>
+          <a:xfrm>
+            <a:off x="4480560" y="4233672"/>
+            <a:ext cx="6949440" cy="914400"/>
+          </a:xfrm>
+          <a:prstGeom prst="rect">
+            <a:avLst/>
+          </a:prstGeom>
+          <a:noFill/>
+        </p:spPr>
+        <p:txBody>
+          <a:bodyPr wrap="square" anchor="ctr" lIns="25400" rIns="25400" tIns="25400" bIns="25400">
+            <a:spAutoFit/>
+          </a:bodyPr>
+          <a:lstStyle/>
+          <a:p>
+            <a:pPr algn="l">
+              <a:lnSpc>
+                <a:spcPct val="105000"/>
+              </a:lnSpc>
+              <a:spcAft>
+                <a:spcPts val="400"/>
+              </a:spcAft>
+            </a:pPr>
+            <a:r>
+              <a:rPr sz="1350" b="0">
+                <a:solidFill>
+                  <a:srgbClr val="2B252A"/>
+                </a:solidFill>
+                <a:latin typeface="Arial"/>
+              </a:rPr>
+              <a:t>symptoms last a median 7.4 years — half of women quit within 1; 62% stop abruptly against advice, 84% relapse</a:t>
+            </a:r>
+          </a:p>
+        </p:txBody>
+      </p:sp>
+      <p:sp>
+        <p:nvSpPr>
+          <p:cNvPr id="18" name="Rounded Rectangle 17"/>
+          <p:cNvSpPr/>
+          <p:nvPr/>
+        </p:nvSpPr>
+        <p:spPr>
+          <a:xfrm>
+            <a:off x="548640" y="5349240"/>
+            <a:ext cx="11064240" cy="777240"/>
+          </a:xfrm>
+          <a:prstGeom prst="roundRect">
             <a:avLst/>
           </a:prstGeom>
           <a:solidFill>
@@ -8793,14 +9582,65 @@
       </p:sp>
       <p:sp>
         <p:nvSpPr>
-          <p:cNvPr id="11" name="TextBox 10"/>
+          <p:cNvPr id="19" name="TextBox 18"/>
           <p:cNvSpPr txBox="1"/>
           <p:nvPr/>
         </p:nvSpPr>
         <p:spPr>
           <a:xfrm>
-            <a:off x="777240" y="2697480"/>
-            <a:ext cx="3145536" cy="822960"/>
+            <a:off x="822960" y="5349240"/>
+            <a:ext cx="10515600" cy="777240"/>
+          </a:xfrm>
+          <a:prstGeom prst="rect">
+            <a:avLst/>
+          </a:prstGeom>
+          <a:noFill/>
+        </p:spPr>
+        <p:txBody>
+          <a:bodyPr wrap="square" anchor="ctr" lIns="25400" rIns="25400" tIns="25400" bIns="25400">
+            <a:spAutoFit/>
+          </a:bodyPr>
+          <a:lstStyle/>
+          <a:p>
+            <a:pPr algn="l">
+              <a:lnSpc>
+                <a:spcPct val="100000"/>
+              </a:lnSpc>
+              <a:spcAft>
+                <a:spcPts val="400"/>
+              </a:spcAft>
+            </a:pPr>
+            <a:r>
+              <a:rPr sz="1800" b="1">
+                <a:solidFill>
+                  <a:srgbClr val="FFFFFF"/>
+                </a:solidFill>
+                <a:latin typeface="Arial"/>
+              </a:rPr>
+              <a:t>Titration is a craft run on recall. </a:t>
+            </a:r>
+            <a:r>
+              <a:rPr sz="1800" b="1">
+                <a:solidFill>
+                  <a:srgbClr val="C89B3C"/>
+                </a:solidFill>
+                <a:latin typeface="Arial"/>
+              </a:rPr>
+              <a:t>It should be a data problem.</a:t>
+            </a:r>
+          </a:p>
+        </p:txBody>
+      </p:sp>
+      <p:sp>
+        <p:nvSpPr>
+          <p:cNvPr id="20" name="TextBox 19"/>
+          <p:cNvSpPr txBox="1"/>
+          <p:nvPr/>
+        </p:nvSpPr>
+        <p:spPr>
+          <a:xfrm>
+            <a:off x="548640" y="6217920"/>
+            <a:ext cx="11064240" cy="320040"/>
           </a:xfrm>
           <a:prstGeom prst="rect">
             <a:avLst/>
@@ -8822,454 +9662,13 @@
               </a:spcAft>
             </a:pPr>
             <a:r>
-              <a:rPr sz="3000" b="1">
-                <a:solidFill>
-                  <a:srgbClr val="4A1F3D"/>
-                </a:solidFill>
-                <a:latin typeface="Arial"/>
-              </a:rPr>
-              <a:t>3–6 months</a:t>
-            </a:r>
-          </a:p>
-        </p:txBody>
-      </p:sp>
-      <p:sp>
-        <p:nvSpPr>
-          <p:cNvPr id="12" name="TextBox 11"/>
-          <p:cNvSpPr txBox="1"/>
-          <p:nvPr/>
-        </p:nvSpPr>
-        <p:spPr>
-          <a:xfrm>
-            <a:off x="777240" y="3611880"/>
-            <a:ext cx="3145536" cy="1005840"/>
-          </a:xfrm>
-          <a:prstGeom prst="rect">
-            <a:avLst/>
-          </a:prstGeom>
-          <a:noFill/>
-        </p:spPr>
-        <p:txBody>
-          <a:bodyPr wrap="square" anchor="t" lIns="25400" rIns="25400" tIns="25400" bIns="25400">
-            <a:spAutoFit/>
-          </a:bodyPr>
-          <a:lstStyle/>
-          <a:p>
-            <a:pPr algn="l">
-              <a:lnSpc>
-                <a:spcPct val="110000"/>
-              </a:lnSpc>
-              <a:spcAft>
-                <a:spcPts val="400"/>
-              </a:spcAft>
-            </a:pPr>
-            <a:r>
-              <a:rPr sz="1350" b="0">
-                <a:solidFill>
-                  <a:srgbClr val="2B252A"/>
-                </a:solidFill>
-                <a:latin typeface="Arial"/>
-              </a:rPr>
-              <a:t>to find a stable dose; every change needs 4–6 weeks to judge</a:t>
-            </a:r>
-          </a:p>
-        </p:txBody>
-      </p:sp>
-      <p:sp>
-        <p:nvSpPr>
-          <p:cNvPr id="13" name="Rounded Rectangle 12"/>
-          <p:cNvSpPr/>
-          <p:nvPr/>
-        </p:nvSpPr>
-        <p:spPr>
-          <a:xfrm>
-            <a:off x="4279392" y="2423160"/>
-            <a:ext cx="3602736" cy="2286000"/>
-          </a:xfrm>
-          <a:prstGeom prst="roundRect">
-            <a:avLst/>
-          </a:prstGeom>
-          <a:solidFill>
-            <a:srgbClr val="FBF8FA"/>
-          </a:solidFill>
-          <a:ln w="12700">
-            <a:solidFill>
-              <a:srgbClr val="E3D8DF"/>
-            </a:solidFill>
-          </a:ln>
-          <a:effectLst/>
-        </p:spPr>
-        <p:style>
-          <a:lnRef idx="1">
-            <a:schemeClr val="accent1"/>
-          </a:lnRef>
-          <a:fillRef idx="3">
-            <a:schemeClr val="accent1"/>
-          </a:fillRef>
-          <a:effectRef idx="2">
-            <a:schemeClr val="accent1"/>
-          </a:effectRef>
-          <a:fontRef idx="minor">
-            <a:schemeClr val="lt1"/>
-          </a:fontRef>
-        </p:style>
-        <p:txBody>
-          <a:bodyPr rtlCol="0" anchor="ctr"/>
-          <a:lstStyle/>
-          <a:p>
-            <a:pPr algn="ctr"/>
-          </a:p>
-        </p:txBody>
-      </p:sp>
-      <p:sp>
-        <p:nvSpPr>
-          <p:cNvPr id="14" name="Rectangle 13"/>
-          <p:cNvSpPr/>
-          <p:nvPr/>
-        </p:nvSpPr>
-        <p:spPr>
-          <a:xfrm>
-            <a:off x="4279392" y="2423160"/>
-            <a:ext cx="3602736" cy="109728"/>
-          </a:xfrm>
-          <a:prstGeom prst="rect">
-            <a:avLst/>
-          </a:prstGeom>
-          <a:solidFill>
-            <a:srgbClr val="C96F8A"/>
-          </a:solidFill>
-          <a:ln>
-            <a:noFill/>
-          </a:ln>
-          <a:effectLst/>
-        </p:spPr>
-        <p:style>
-          <a:lnRef idx="1">
-            <a:schemeClr val="accent1"/>
-          </a:lnRef>
-          <a:fillRef idx="3">
-            <a:schemeClr val="accent1"/>
-          </a:fillRef>
-          <a:effectRef idx="2">
-            <a:schemeClr val="accent1"/>
-          </a:effectRef>
-          <a:fontRef idx="minor">
-            <a:schemeClr val="lt1"/>
-          </a:fontRef>
-        </p:style>
-        <p:txBody>
-          <a:bodyPr rtlCol="0" anchor="ctr"/>
-          <a:lstStyle/>
-          <a:p>
-            <a:pPr algn="ctr"/>
-          </a:p>
-        </p:txBody>
-      </p:sp>
-      <p:sp>
-        <p:nvSpPr>
-          <p:cNvPr id="15" name="TextBox 14"/>
-          <p:cNvSpPr txBox="1"/>
-          <p:nvPr/>
-        </p:nvSpPr>
-        <p:spPr>
-          <a:xfrm>
-            <a:off x="4507992" y="2697480"/>
-            <a:ext cx="3145536" cy="822960"/>
-          </a:xfrm>
-          <a:prstGeom prst="rect">
-            <a:avLst/>
-          </a:prstGeom>
-          <a:noFill/>
-        </p:spPr>
-        <p:txBody>
-          <a:bodyPr wrap="square" anchor="t" lIns="25400" rIns="25400" tIns="25400" bIns="25400">
-            <a:spAutoFit/>
-          </a:bodyPr>
-          <a:lstStyle/>
-          <a:p>
-            <a:pPr algn="l">
-              <a:lnSpc>
-                <a:spcPct val="100000"/>
-              </a:lnSpc>
-              <a:spcAft>
-                <a:spcPts val="400"/>
-              </a:spcAft>
-            </a:pPr>
-            <a:r>
-              <a:rPr sz="3000" b="1">
-                <a:solidFill>
-                  <a:srgbClr val="C96F8A"/>
-                </a:solidFill>
-                <a:latin typeface="Arial"/>
-              </a:rPr>
-              <a:t>~50%</a:t>
-            </a:r>
-          </a:p>
-        </p:txBody>
-      </p:sp>
-      <p:sp>
-        <p:nvSpPr>
-          <p:cNvPr id="16" name="TextBox 15"/>
-          <p:cNvSpPr txBox="1"/>
-          <p:nvPr/>
-        </p:nvSpPr>
-        <p:spPr>
-          <a:xfrm>
-            <a:off x="4507992" y="3611880"/>
-            <a:ext cx="3145536" cy="1005840"/>
-          </a:xfrm>
-          <a:prstGeom prst="rect">
-            <a:avLst/>
-          </a:prstGeom>
-          <a:noFill/>
-        </p:spPr>
-        <p:txBody>
-          <a:bodyPr wrap="square" anchor="t" lIns="25400" rIns="25400" tIns="25400" bIns="25400">
-            <a:spAutoFit/>
-          </a:bodyPr>
-          <a:lstStyle/>
-          <a:p>
-            <a:pPr algn="l">
-              <a:lnSpc>
-                <a:spcPct val="110000"/>
-              </a:lnSpc>
-              <a:spcAft>
-                <a:spcPts val="400"/>
-              </a:spcAft>
-            </a:pPr>
-            <a:r>
-              <a:rPr sz="1350" b="0">
-                <a:solidFill>
-                  <a:srgbClr val="2B252A"/>
-                </a:solidFill>
-                <a:latin typeface="Arial"/>
-              </a:rPr>
-              <a:t>quit HRT in the first year — 64–87% of them blame side-effects (i.e. the dose was never dialled in)</a:t>
-            </a:r>
-          </a:p>
-        </p:txBody>
-      </p:sp>
-      <p:sp>
-        <p:nvSpPr>
-          <p:cNvPr id="17" name="Rounded Rectangle 16"/>
-          <p:cNvSpPr/>
-          <p:nvPr/>
-        </p:nvSpPr>
-        <p:spPr>
-          <a:xfrm>
-            <a:off x="8010144" y="2423160"/>
-            <a:ext cx="3602736" cy="2286000"/>
-          </a:xfrm>
-          <a:prstGeom prst="roundRect">
-            <a:avLst/>
-          </a:prstGeom>
-          <a:solidFill>
-            <a:srgbClr val="FBF8FA"/>
-          </a:solidFill>
-          <a:ln w="12700">
-            <a:solidFill>
-              <a:srgbClr val="E3D8DF"/>
-            </a:solidFill>
-          </a:ln>
-          <a:effectLst/>
-        </p:spPr>
-        <p:style>
-          <a:lnRef idx="1">
-            <a:schemeClr val="accent1"/>
-          </a:lnRef>
-          <a:fillRef idx="3">
-            <a:schemeClr val="accent1"/>
-          </a:fillRef>
-          <a:effectRef idx="2">
-            <a:schemeClr val="accent1"/>
-          </a:effectRef>
-          <a:fontRef idx="minor">
-            <a:schemeClr val="lt1"/>
-          </a:fontRef>
-        </p:style>
-        <p:txBody>
-          <a:bodyPr rtlCol="0" anchor="ctr"/>
-          <a:lstStyle/>
-          <a:p>
-            <a:pPr algn="ctr"/>
-          </a:p>
-        </p:txBody>
-      </p:sp>
-      <p:sp>
-        <p:nvSpPr>
-          <p:cNvPr id="18" name="Rectangle 17"/>
-          <p:cNvSpPr/>
-          <p:nvPr/>
-        </p:nvSpPr>
-        <p:spPr>
-          <a:xfrm>
-            <a:off x="8010144" y="2423160"/>
-            <a:ext cx="3602736" cy="109728"/>
-          </a:xfrm>
-          <a:prstGeom prst="rect">
-            <a:avLst/>
-          </a:prstGeom>
-          <a:solidFill>
-            <a:srgbClr val="6E335C"/>
-          </a:solidFill>
-          <a:ln>
-            <a:noFill/>
-          </a:ln>
-          <a:effectLst/>
-        </p:spPr>
-        <p:style>
-          <a:lnRef idx="1">
-            <a:schemeClr val="accent1"/>
-          </a:lnRef>
-          <a:fillRef idx="3">
-            <a:schemeClr val="accent1"/>
-          </a:fillRef>
-          <a:effectRef idx="2">
-            <a:schemeClr val="accent1"/>
-          </a:effectRef>
-          <a:fontRef idx="minor">
-            <a:schemeClr val="lt1"/>
-          </a:fontRef>
-        </p:style>
-        <p:txBody>
-          <a:bodyPr rtlCol="0" anchor="ctr"/>
-          <a:lstStyle/>
-          <a:p>
-            <a:pPr algn="ctr"/>
-          </a:p>
-        </p:txBody>
-      </p:sp>
-      <p:sp>
-        <p:nvSpPr>
-          <p:cNvPr id="19" name="TextBox 18"/>
-          <p:cNvSpPr txBox="1"/>
-          <p:nvPr/>
-        </p:nvSpPr>
-        <p:spPr>
-          <a:xfrm>
-            <a:off x="8238744" y="2697480"/>
-            <a:ext cx="3145536" cy="822960"/>
-          </a:xfrm>
-          <a:prstGeom prst="rect">
-            <a:avLst/>
-          </a:prstGeom>
-          <a:noFill/>
-        </p:spPr>
-        <p:txBody>
-          <a:bodyPr wrap="square" anchor="t" lIns="25400" rIns="25400" tIns="25400" bIns="25400">
-            <a:spAutoFit/>
-          </a:bodyPr>
-          <a:lstStyle/>
-          <a:p>
-            <a:pPr algn="l">
-              <a:lnSpc>
-                <a:spcPct val="100000"/>
-              </a:lnSpc>
-              <a:spcAft>
-                <a:spcPts val="400"/>
-              </a:spcAft>
-            </a:pPr>
-            <a:r>
-              <a:rPr sz="3000" b="1">
-                <a:solidFill>
-                  <a:srgbClr val="6E335C"/>
-                </a:solidFill>
-                <a:latin typeface="Arial"/>
-              </a:rPr>
-              <a:t>The blind window</a:t>
-            </a:r>
-          </a:p>
-        </p:txBody>
-      </p:sp>
-      <p:sp>
-        <p:nvSpPr>
-          <p:cNvPr id="20" name="TextBox 19"/>
-          <p:cNvSpPr txBox="1"/>
-          <p:nvPr/>
-        </p:nvSpPr>
-        <p:spPr>
-          <a:xfrm>
-            <a:off x="8238744" y="3611880"/>
-            <a:ext cx="3145536" cy="1005840"/>
-          </a:xfrm>
-          <a:prstGeom prst="rect">
-            <a:avLst/>
-          </a:prstGeom>
-          <a:noFill/>
-        </p:spPr>
-        <p:txBody>
-          <a:bodyPr wrap="square" anchor="t" lIns="25400" rIns="25400" tIns="25400" bIns="25400">
-            <a:spAutoFit/>
-          </a:bodyPr>
-          <a:lstStyle/>
-          <a:p>
-            <a:pPr algn="l">
-              <a:lnSpc>
-                <a:spcPct val="110000"/>
-              </a:lnSpc>
-              <a:spcAft>
-                <a:spcPts val="400"/>
-              </a:spcAft>
-            </a:pPr>
-            <a:r>
-              <a:rPr sz="1350" b="0">
-                <a:solidFill>
-                  <a:srgbClr val="2B252A"/>
-                </a:solidFill>
-                <a:latin typeface="Arial"/>
-              </a:rPr>
-              <a:t>panic-quitting peaks at weeks 2–3; the first follow-up is week 6–12</a:t>
-            </a:r>
-          </a:p>
-        </p:txBody>
-      </p:sp>
-      <p:sp>
-        <p:nvSpPr>
-          <p:cNvPr id="21" name="TextBox 20"/>
-          <p:cNvSpPr txBox="1"/>
-          <p:nvPr/>
-        </p:nvSpPr>
-        <p:spPr>
-          <a:xfrm>
-            <a:off x="548640" y="5074920"/>
-            <a:ext cx="11064240" cy="1188720"/>
-          </a:xfrm>
-          <a:prstGeom prst="rect">
-            <a:avLst/>
-          </a:prstGeom>
-          <a:noFill/>
-        </p:spPr>
-        <p:txBody>
-          <a:bodyPr wrap="square" anchor="t" lIns="25400" rIns="25400" tIns="25400" bIns="25400">
-            <a:spAutoFit/>
-          </a:bodyPr>
-          <a:lstStyle/>
-          <a:p>
-            <a:pPr algn="l">
-              <a:lnSpc>
-                <a:spcPct val="115000"/>
-              </a:lnSpc>
-              <a:spcAft>
-                <a:spcPts val="400"/>
-              </a:spcAft>
-            </a:pPr>
-            <a:r>
-              <a:rPr sz="1500" b="1">
-                <a:solidFill>
-                  <a:srgbClr val="4A1F3D"/>
-                </a:solidFill>
-                <a:latin typeface="Arial"/>
-              </a:rPr>
-              <a:t>The core failure: </a:t>
-            </a:r>
-            <a:r>
-              <a:rPr sz="1500" b="0">
-                <a:solidFill>
-                  <a:srgbClr val="2B252A"/>
-                </a:solidFill>
-                <a:latin typeface="Arial"/>
-              </a:rPr>
-              <a:t>the patient suffers in an information vacuum for months, the clinician re-doses on a vague recall ("uh… not great?"), and half the treatment dies before it stabilises. This window is invisible to today's system.</a:t>
+              <a:rPr sz="1100" b="0">
+                <a:solidFill>
+                  <a:srgbClr val="6B6368"/>
+                </a:solidFill>
+                <a:latin typeface="Arial"/>
+              </a:rPr>
+              <a:t>$13B/yr out-of-pocket on low-evidence workarounds  ·  symptomatic women incur +45% healthcare costs</a:t>
             </a:r>
           </a:p>
         </p:txBody>
@@ -17270,4 +17669,324 @@
   </a:objectDefaults>
   <a:extraClrSchemeLst/>
 </a:theme>
+</file>
+
+<file path=ppt/theme/theme2.xml><?xml version="1.0" encoding="utf-8"?>
+<a:theme xmlns:a="http://schemas.openxmlformats.org/drawingml/2006/main" name="Office Theme">
+  <a:themeElements>
+    <a:clrScheme name="Office">
+      <a:dk1>
+        <a:sysClr val="windowText" lastClr="000000"/>
+      </a:dk1>
+      <a:lt1>
+        <a:sysClr val="window" lastClr="FFFFFF"/>
+      </a:lt1>
+      <a:dk2>
+        <a:srgbClr val="1F497D"/>
+      </a:dk2>
+      <a:lt2>
+        <a:srgbClr val="EEECE1"/>
+      </a:lt2>
+      <a:accent1>
+        <a:srgbClr val="4F81BD"/>
+      </a:accent1>
+      <a:accent2>
+        <a:srgbClr val="C0504D"/>
+      </a:accent2>
+      <a:accent3>
+        <a:srgbClr val="9BBB59"/>
+      </a:accent3>
+      <a:accent4>
+        <a:srgbClr val="8064A2"/>
+      </a:accent4>
+      <a:accent5>
+        <a:srgbClr val="4BACC6"/>
+      </a:accent5>
+      <a:accent6>
+        <a:srgbClr val="F79646"/>
+      </a:accent6>
+      <a:hlink>
+        <a:srgbClr val="0000FF"/>
+      </a:hlink>
+      <a:folHlink>
+        <a:srgbClr val="800080"/>
+      </a:folHlink>
+    </a:clrScheme>
+    <a:fontScheme name="Office">
+      <a:majorFont>
+        <a:latin typeface="Calibri"/>
+        <a:ea typeface=""/>
+        <a:cs typeface=""/>
+        <a:font script="Jpan" typeface="ＭＳ Ｐゴシック"/>
+        <a:font script="Hang" typeface="맑은 고딕"/>
+        <a:font script="Hans" typeface="宋体"/>
+        <a:font script="Hant" typeface="新細明體"/>
+        <a:font script="Arab" typeface="Times New Roman"/>
+        <a:font script="Hebr" typeface="Times New Roman"/>
+        <a:font script="Thai" typeface="Angsana New"/>
+        <a:font script="Ethi" typeface="Nyala"/>
+        <a:font script="Beng" typeface="Vrinda"/>
+        <a:font script="Gujr" typeface="Shruti"/>
+        <a:font script="Khmr" typeface="MoolBoran"/>
+        <a:font script="Knda" typeface="Tunga"/>
+        <a:font script="Guru" typeface="Raavi"/>
+        <a:font script="Cans" typeface="Euphemia"/>
+        <a:font script="Cher" typeface="Plantagenet Cherokee"/>
+        <a:font script="Yiii" typeface="Microsoft Yi Baiti"/>
+        <a:font script="Tibt" typeface="Microsoft Himalaya"/>
+        <a:font script="Thaa" typeface="MV Boli"/>
+        <a:font script="Deva" typeface="Mangal"/>
+        <a:font script="Telu" typeface="Gautami"/>
+        <a:font script="Taml" typeface="Latha"/>
+        <a:font script="Syrc" typeface="Estrangelo Edessa"/>
+        <a:font script="Orya" typeface="Kalinga"/>
+        <a:font script="Mlym" typeface="Kartika"/>
+        <a:font script="Laoo" typeface="DokChampa"/>
+        <a:font script="Sinh" typeface="Iskoola Pota"/>
+        <a:font script="Mong" typeface="Mongolian Baiti"/>
+        <a:font script="Viet" typeface="Times New Roman"/>
+        <a:font script="Uigh" typeface="Microsoft Uighur"/>
+        <a:font script="Geor" typeface="Sylfaen"/>
+      </a:majorFont>
+      <a:minorFont>
+        <a:latin typeface="Calibri"/>
+        <a:ea typeface=""/>
+        <a:cs typeface=""/>
+        <a:font script="Jpan" typeface="ＭＳ Ｐゴシック"/>
+        <a:font script="Hang" typeface="맑은 고딕"/>
+        <a:font script="Hans" typeface="宋体"/>
+        <a:font script="Hant" typeface="新細明體"/>
+        <a:font script="Arab" typeface="Arial"/>
+        <a:font script="Hebr" typeface="Arial"/>
+        <a:font script="Thai" typeface="Cordia New"/>
+        <a:font script="Ethi" typeface="Nyala"/>
+        <a:font script="Beng" typeface="Vrinda"/>
+        <a:font script="Gujr" typeface="Shruti"/>
+        <a:font script="Khmr" typeface="DaunPenh"/>
+        <a:font script="Knda" typeface="Tunga"/>
+        <a:font script="Guru" typeface="Raavi"/>
+        <a:font script="Cans" typeface="Euphemia"/>
+        <a:font script="Cher" typeface="Plantagenet Cherokee"/>
+        <a:font script="Yiii" typeface="Microsoft Yi Baiti"/>
+        <a:font script="Tibt" typeface="Microsoft Himalaya"/>
+        <a:font script="Thaa" typeface="MV Boli"/>
+        <a:font script="Deva" typeface="Mangal"/>
+        <a:font script="Telu" typeface="Gautami"/>
+        <a:font script="Taml" typeface="Latha"/>
+        <a:font script="Syrc" typeface="Estrangelo Edessa"/>
+        <a:font script="Orya" typeface="Kalinga"/>
+        <a:font script="Mlym" typeface="Kartika"/>
+        <a:font script="Laoo" typeface="DokChampa"/>
+        <a:font script="Sinh" typeface="Iskoola Pota"/>
+        <a:font script="Mong" typeface="Mongolian Baiti"/>
+        <a:font script="Viet" typeface="Arial"/>
+        <a:font script="Uigh" typeface="Microsoft Uighur"/>
+        <a:font script="Geor" typeface="Sylfaen"/>
+      </a:minorFont>
+    </a:fontScheme>
+    <a:fmtScheme name="Office">
+      <a:fillStyleLst>
+        <a:solidFill>
+          <a:schemeClr val="phClr"/>
+        </a:solidFill>
+        <a:gradFill rotWithShape="1">
+          <a:gsLst>
+            <a:gs pos="0">
+              <a:schemeClr val="phClr">
+                <a:tint val="50000"/>
+                <a:satMod val="300000"/>
+              </a:schemeClr>
+            </a:gs>
+            <a:gs pos="35000">
+              <a:schemeClr val="phClr">
+                <a:tint val="37000"/>
+                <a:satMod val="300000"/>
+              </a:schemeClr>
+            </a:gs>
+            <a:gs pos="100000">
+              <a:schemeClr val="phClr">
+                <a:tint val="15000"/>
+                <a:satMod val="350000"/>
+              </a:schemeClr>
+            </a:gs>
+          </a:gsLst>
+          <a:lin ang="16200000" scaled="1"/>
+        </a:gradFill>
+        <a:gradFill rotWithShape="1">
+          <a:gsLst>
+            <a:gs pos="0">
+              <a:schemeClr val="phClr">
+                <a:tint val="100000"/>
+                <a:shade val="100000"/>
+                <a:satMod val="130000"/>
+              </a:schemeClr>
+            </a:gs>
+            <a:gs pos="100000">
+              <a:schemeClr val="phClr">
+                <a:tint val="50000"/>
+                <a:shade val="100000"/>
+                <a:satMod val="350000"/>
+              </a:schemeClr>
+            </a:gs>
+          </a:gsLst>
+          <a:lin ang="16200000" scaled="0"/>
+        </a:gradFill>
+      </a:fillStyleLst>
+      <a:lnStyleLst>
+        <a:ln w="9525" cap="flat" cmpd="sng" algn="ctr">
+          <a:solidFill>
+            <a:schemeClr val="phClr">
+              <a:shade val="95000"/>
+              <a:satMod val="105000"/>
+            </a:schemeClr>
+          </a:solidFill>
+          <a:prstDash val="solid"/>
+        </a:ln>
+        <a:ln w="25400" cap="flat" cmpd="sng" algn="ctr">
+          <a:solidFill>
+            <a:schemeClr val="phClr"/>
+          </a:solidFill>
+          <a:prstDash val="solid"/>
+        </a:ln>
+        <a:ln w="38100" cap="flat" cmpd="sng" algn="ctr">
+          <a:solidFill>
+            <a:schemeClr val="phClr"/>
+          </a:solidFill>
+          <a:prstDash val="solid"/>
+        </a:ln>
+      </a:lnStyleLst>
+      <a:effectStyleLst>
+        <a:effectStyle>
+          <a:effectLst>
+            <a:outerShdw blurRad="40000" dist="20000" dir="5400000" rotWithShape="0">
+              <a:srgbClr val="000000">
+                <a:alpha val="38000"/>
+              </a:srgbClr>
+            </a:outerShdw>
+          </a:effectLst>
+        </a:effectStyle>
+        <a:effectStyle>
+          <a:effectLst>
+            <a:outerShdw blurRad="40000" dist="23000" dir="5400000" rotWithShape="0">
+              <a:srgbClr val="000000">
+                <a:alpha val="35000"/>
+              </a:srgbClr>
+            </a:outerShdw>
+          </a:effectLst>
+        </a:effectStyle>
+        <a:effectStyle>
+          <a:effectLst>
+            <a:outerShdw blurRad="40000" dist="23000" dir="5400000" rotWithShape="0">
+              <a:srgbClr val="000000">
+                <a:alpha val="35000"/>
+              </a:srgbClr>
+            </a:outerShdw>
+          </a:effectLst>
+          <a:scene3d>
+            <a:camera prst="orthographicFront">
+              <a:rot lat="0" lon="0" rev="0"/>
+            </a:camera>
+            <a:lightRig rig="threePt" dir="t">
+              <a:rot lat="0" lon="0" rev="1200000"/>
+            </a:lightRig>
+          </a:scene3d>
+          <a:sp3d>
+            <a:bevelT w="63500" h="25400"/>
+          </a:sp3d>
+        </a:effectStyle>
+      </a:effectStyleLst>
+      <a:bgFillStyleLst>
+        <a:solidFill>
+          <a:schemeClr val="phClr"/>
+        </a:solidFill>
+        <a:gradFill rotWithShape="1">
+          <a:gsLst>
+            <a:gs pos="0">
+              <a:schemeClr val="phClr">
+                <a:tint val="40000"/>
+                <a:satMod val="350000"/>
+              </a:schemeClr>
+            </a:gs>
+            <a:gs pos="40000">
+              <a:schemeClr val="phClr">
+                <a:tint val="45000"/>
+                <a:shade val="99000"/>
+                <a:satMod val="350000"/>
+              </a:schemeClr>
+            </a:gs>
+            <a:gs pos="100000">
+              <a:schemeClr val="phClr">
+                <a:shade val="20000"/>
+                <a:satMod val="255000"/>
+              </a:schemeClr>
+            </a:gs>
+          </a:gsLst>
+          <a:path path="circle">
+            <a:fillToRect l="50000" t="-80000" r="50000" b="180000"/>
+          </a:path>
+        </a:gradFill>
+        <a:gradFill rotWithShape="1">
+          <a:gsLst>
+            <a:gs pos="0">
+              <a:schemeClr val="phClr">
+                <a:tint val="80000"/>
+                <a:satMod val="300000"/>
+              </a:schemeClr>
+            </a:gs>
+            <a:gs pos="100000">
+              <a:schemeClr val="phClr">
+                <a:shade val="30000"/>
+                <a:satMod val="200000"/>
+              </a:schemeClr>
+            </a:gs>
+          </a:gsLst>
+          <a:path path="circle">
+            <a:fillToRect l="50000" t="50000" r="50000" b="50000"/>
+          </a:path>
+        </a:gradFill>
+      </a:bgFillStyleLst>
+    </a:fmtScheme>
+  </a:themeElements>
+  <a:objectDefaults>
+    <a:spDef>
+      <a:spPr/>
+      <a:bodyPr/>
+      <a:lstStyle/>
+      <a:style>
+        <a:lnRef idx="1">
+          <a:schemeClr val="accent1"/>
+        </a:lnRef>
+        <a:fillRef idx="3">
+          <a:schemeClr val="accent1"/>
+        </a:fillRef>
+        <a:effectRef idx="2">
+          <a:schemeClr val="accent1"/>
+        </a:effectRef>
+        <a:fontRef idx="minor">
+          <a:schemeClr val="lt1"/>
+        </a:fontRef>
+      </a:style>
+    </a:spDef>
+    <a:lnDef>
+      <a:spPr/>
+      <a:bodyPr/>
+      <a:lstStyle/>
+      <a:style>
+        <a:lnRef idx="2">
+          <a:schemeClr val="accent1"/>
+        </a:lnRef>
+        <a:fillRef idx="0">
+          <a:schemeClr val="accent1"/>
+        </a:fillRef>
+        <a:effectRef idx="1">
+          <a:schemeClr val="accent1"/>
+        </a:effectRef>
+        <a:fontRef idx="minor">
+          <a:schemeClr val="tx1"/>
+        </a:fontRef>
+      </a:style>
+    </a:lnDef>
+  </a:objectDefaults>
+  <a:extraClrSchemeLst/>
+</a:theme>
 </file>
</xml_diff>